<commit_message>
Harden pptx generation: avoid slide.background XML, use plain rectangle shapes instead
</commit_message>
<xml_diff>
--- a/docs/DockPulse_Deck.pptx
+++ b/docs/DockPulse_Deck.pptx
@@ -4140,14 +4140,6 @@
 <file path=ppt/slides/slide1.xml><?xml version="1.0" encoding="utf-8"?>
 <p:sld xmlns:a="http://schemas.openxmlformats.org/drawingml/2006/main" xmlns:p="http://schemas.openxmlformats.org/presentationml/2006/main" xmlns:r="http://schemas.openxmlformats.org/officeDocument/2006/relationships">
   <p:cSld>
-    <p:bg>
-      <p:bgPr>
-        <a:solidFill>
-          <a:srgbClr val="11141A"/>
-        </a:solidFill>
-        <a:effectLst/>
-      </p:bgPr>
-    </p:bg>
     <p:spTree>
       <p:nvGrpSpPr>
         <p:cNvPr id="1" name=""/>
@@ -4163,6 +4155,49 @@
         </p:nvSpPr>
         <p:spPr>
           <a:xfrm>
+            <a:off x="0" y="0"/>
+            <a:ext cx="12191695" cy="6858000"/>
+          </a:xfrm>
+          <a:prstGeom prst="rect">
+            <a:avLst/>
+          </a:prstGeom>
+          <a:solidFill>
+            <a:srgbClr val="11141A"/>
+          </a:solidFill>
+          <a:ln>
+            <a:noFill/>
+          </a:ln>
+        </p:spPr>
+        <p:style>
+          <a:lnRef idx="1">
+            <a:schemeClr val="accent1"/>
+          </a:lnRef>
+          <a:fillRef idx="3">
+            <a:schemeClr val="accent1"/>
+          </a:fillRef>
+          <a:effectRef idx="2">
+            <a:schemeClr val="accent1"/>
+          </a:effectRef>
+          <a:fontRef idx="minor">
+            <a:schemeClr val="lt1"/>
+          </a:fontRef>
+        </p:style>
+        <p:txBody>
+          <a:bodyPr rtlCol="0" anchor="ctr"/>
+          <a:lstStyle/>
+          <a:p>
+            <a:pPr algn="ctr"/>
+          </a:p>
+        </p:txBody>
+      </p:sp>
+      <p:sp>
+        <p:nvSpPr>
+          <p:cNvPr id="3" name="Rectangle 2"/>
+          <p:cNvSpPr/>
+          <p:nvPr/>
+        </p:nvSpPr>
+        <p:spPr>
+          <a:xfrm>
             <a:off x="0" y="2788920"/>
             <a:ext cx="12191695" cy="54864"/>
           </a:xfrm>
@@ -4175,7 +4210,6 @@
           <a:ln>
             <a:noFill/>
           </a:ln>
-          <a:effectLst/>
         </p:spPr>
         <p:style>
           <a:lnRef idx="1">
@@ -4201,7 +4235,7 @@
       </p:sp>
       <p:sp>
         <p:nvSpPr>
-          <p:cNvPr id="3" name="TextBox 2"/>
+          <p:cNvPr id="4" name="TextBox 3"/>
           <p:cNvSpPr txBox="1"/>
           <p:nvPr/>
         </p:nvSpPr>
@@ -4236,7 +4270,7 @@
       </p:sp>
       <p:sp>
         <p:nvSpPr>
-          <p:cNvPr id="4" name="TextBox 3"/>
+          <p:cNvPr id="5" name="TextBox 4"/>
           <p:cNvSpPr txBox="1"/>
           <p:nvPr/>
         </p:nvSpPr>
@@ -4271,7 +4305,7 @@
       </p:sp>
       <p:sp>
         <p:nvSpPr>
-          <p:cNvPr id="5" name="TextBox 4"/>
+          <p:cNvPr id="6" name="TextBox 5"/>
           <p:cNvSpPr txBox="1"/>
           <p:nvPr/>
         </p:nvSpPr>
@@ -4306,7 +4340,7 @@
       </p:sp>
       <p:sp>
         <p:nvSpPr>
-          <p:cNvPr id="6" name="Rounded Rectangle 5"/>
+          <p:cNvPr id="7" name="Rounded Rectangle 6"/>
           <p:cNvSpPr/>
           <p:nvPr/>
         </p:nvSpPr>
@@ -4324,7 +4358,6 @@
           <a:ln>
             <a:noFill/>
           </a:ln>
-          <a:effectLst/>
         </p:spPr>
         <p:style>
           <a:lnRef idx="1">
@@ -4359,7 +4392,7 @@
       </p:sp>
       <p:sp>
         <p:nvSpPr>
-          <p:cNvPr id="7" name="Rounded Rectangle 6"/>
+          <p:cNvPr id="8" name="Rounded Rectangle 7"/>
           <p:cNvSpPr/>
           <p:nvPr/>
         </p:nvSpPr>
@@ -4377,7 +4410,6 @@
           <a:ln>
             <a:noFill/>
           </a:ln>
-          <a:effectLst/>
         </p:spPr>
         <p:style>
           <a:lnRef idx="1">
@@ -4412,7 +4444,7 @@
       </p:sp>
       <p:sp>
         <p:nvSpPr>
-          <p:cNvPr id="8" name="Rounded Rectangle 7"/>
+          <p:cNvPr id="9" name="Rounded Rectangle 8"/>
           <p:cNvSpPr/>
           <p:nvPr/>
         </p:nvSpPr>
@@ -4430,7 +4462,6 @@
           <a:ln>
             <a:noFill/>
           </a:ln>
-          <a:effectLst/>
         </p:spPr>
         <p:style>
           <a:lnRef idx="1">
@@ -4465,7 +4496,7 @@
       </p:sp>
       <p:sp>
         <p:nvSpPr>
-          <p:cNvPr id="9" name="Rounded Rectangle 8"/>
+          <p:cNvPr id="10" name="Rounded Rectangle 9"/>
           <p:cNvSpPr/>
           <p:nvPr/>
         </p:nvSpPr>
@@ -4483,7 +4514,6 @@
           <a:ln>
             <a:noFill/>
           </a:ln>
-          <a:effectLst/>
         </p:spPr>
         <p:style>
           <a:lnRef idx="1">
@@ -4518,7 +4548,7 @@
       </p:sp>
       <p:sp>
         <p:nvSpPr>
-          <p:cNvPr id="10" name="TextBox 9"/>
+          <p:cNvPr id="11" name="TextBox 10"/>
           <p:cNvSpPr txBox="1"/>
           <p:nvPr/>
         </p:nvSpPr>
@@ -4562,14 +4592,6 @@
 <file path=ppt/slides/slide10.xml><?xml version="1.0" encoding="utf-8"?>
 <p:sld xmlns:a="http://schemas.openxmlformats.org/drawingml/2006/main" xmlns:p="http://schemas.openxmlformats.org/presentationml/2006/main" xmlns:r="http://schemas.openxmlformats.org/officeDocument/2006/relationships">
   <p:cSld>
-    <p:bg>
-      <p:bgPr>
-        <a:solidFill>
-          <a:srgbClr val="11141A"/>
-        </a:solidFill>
-        <a:effectLst/>
-      </p:bgPr>
-    </p:bg>
     <p:spTree>
       <p:nvGrpSpPr>
         <p:cNvPr id="1" name=""/>
@@ -4585,6 +4607,49 @@
         </p:nvSpPr>
         <p:spPr>
           <a:xfrm>
+            <a:off x="0" y="0"/>
+            <a:ext cx="12191695" cy="6858000"/>
+          </a:xfrm>
+          <a:prstGeom prst="rect">
+            <a:avLst/>
+          </a:prstGeom>
+          <a:solidFill>
+            <a:srgbClr val="11141A"/>
+          </a:solidFill>
+          <a:ln>
+            <a:noFill/>
+          </a:ln>
+        </p:spPr>
+        <p:style>
+          <a:lnRef idx="1">
+            <a:schemeClr val="accent1"/>
+          </a:lnRef>
+          <a:fillRef idx="3">
+            <a:schemeClr val="accent1"/>
+          </a:fillRef>
+          <a:effectRef idx="2">
+            <a:schemeClr val="accent1"/>
+          </a:effectRef>
+          <a:fontRef idx="minor">
+            <a:schemeClr val="lt1"/>
+          </a:fontRef>
+        </p:style>
+        <p:txBody>
+          <a:bodyPr rtlCol="0" anchor="ctr"/>
+          <a:lstStyle/>
+          <a:p>
+            <a:pPr algn="ctr"/>
+          </a:p>
+        </p:txBody>
+      </p:sp>
+      <p:sp>
+        <p:nvSpPr>
+          <p:cNvPr id="3" name="Rectangle 2"/>
+          <p:cNvSpPr/>
+          <p:nvPr/>
+        </p:nvSpPr>
+        <p:spPr>
+          <a:xfrm>
             <a:off x="0" y="2651760"/>
             <a:ext cx="12191695" cy="54864"/>
           </a:xfrm>
@@ -4597,7 +4662,6 @@
           <a:ln>
             <a:noFill/>
           </a:ln>
-          <a:effectLst/>
         </p:spPr>
         <p:style>
           <a:lnRef idx="1">
@@ -4623,7 +4687,7 @@
       </p:sp>
       <p:sp>
         <p:nvSpPr>
-          <p:cNvPr id="3" name="TextBox 2"/>
+          <p:cNvPr id="4" name="TextBox 3"/>
           <p:cNvSpPr txBox="1"/>
           <p:nvPr/>
         </p:nvSpPr>
@@ -4658,7 +4722,7 @@
       </p:sp>
       <p:sp>
         <p:nvSpPr>
-          <p:cNvPr id="4" name="TextBox 3"/>
+          <p:cNvPr id="5" name="TextBox 4"/>
           <p:cNvSpPr txBox="1"/>
           <p:nvPr/>
         </p:nvSpPr>
@@ -4729,7 +4793,7 @@
       </p:sp>
       <p:sp>
         <p:nvSpPr>
-          <p:cNvPr id="5" name="Rounded Rectangle 4"/>
+          <p:cNvPr id="6" name="Rounded Rectangle 5"/>
           <p:cNvSpPr/>
           <p:nvPr/>
         </p:nvSpPr>
@@ -4747,7 +4811,6 @@
           <a:ln>
             <a:noFill/>
           </a:ln>
-          <a:effectLst/>
         </p:spPr>
         <p:style>
           <a:lnRef idx="1">
@@ -4782,7 +4845,7 @@
       </p:sp>
       <p:sp>
         <p:nvSpPr>
-          <p:cNvPr id="6" name="Rounded Rectangle 5"/>
+          <p:cNvPr id="7" name="Rounded Rectangle 6"/>
           <p:cNvSpPr/>
           <p:nvPr/>
         </p:nvSpPr>
@@ -4800,7 +4863,6 @@
           <a:ln>
             <a:noFill/>
           </a:ln>
-          <a:effectLst/>
         </p:spPr>
         <p:style>
           <a:lnRef idx="1">
@@ -4835,7 +4897,7 @@
       </p:sp>
       <p:sp>
         <p:nvSpPr>
-          <p:cNvPr id="7" name="Rounded Rectangle 6"/>
+          <p:cNvPr id="8" name="Rounded Rectangle 7"/>
           <p:cNvSpPr/>
           <p:nvPr/>
         </p:nvSpPr>
@@ -4853,7 +4915,6 @@
           <a:ln>
             <a:noFill/>
           </a:ln>
-          <a:effectLst/>
         </p:spPr>
         <p:style>
           <a:lnRef idx="1">
@@ -4888,7 +4949,7 @@
       </p:sp>
       <p:sp>
         <p:nvSpPr>
-          <p:cNvPr id="8" name="Rounded Rectangle 7"/>
+          <p:cNvPr id="9" name="Rounded Rectangle 8"/>
           <p:cNvSpPr/>
           <p:nvPr/>
         </p:nvSpPr>
@@ -4906,7 +4967,6 @@
           <a:ln>
             <a:noFill/>
           </a:ln>
-          <a:effectLst/>
         </p:spPr>
         <p:style>
           <a:lnRef idx="1">
@@ -4941,7 +5001,7 @@
       </p:sp>
       <p:sp>
         <p:nvSpPr>
-          <p:cNvPr id="9" name="TextBox 8"/>
+          <p:cNvPr id="10" name="TextBox 9"/>
           <p:cNvSpPr txBox="1"/>
           <p:nvPr/>
         </p:nvSpPr>
@@ -4985,14 +5045,6 @@
 <file path=ppt/slides/slide2.xml><?xml version="1.0" encoding="utf-8"?>
 <p:sld xmlns:a="http://schemas.openxmlformats.org/drawingml/2006/main" xmlns:p="http://schemas.openxmlformats.org/presentationml/2006/main" xmlns:r="http://schemas.openxmlformats.org/officeDocument/2006/relationships">
   <p:cSld>
-    <p:bg>
-      <p:bgPr>
-        <a:solidFill>
-          <a:srgbClr val="FFFFFF"/>
-        </a:solidFill>
-        <a:effectLst/>
-      </p:bgPr>
-    </p:bg>
     <p:spTree>
       <p:nvGrpSpPr>
         <p:cNvPr id="1" name=""/>
@@ -5008,6 +5060,49 @@
         </p:nvSpPr>
         <p:spPr>
           <a:xfrm>
+            <a:off x="0" y="0"/>
+            <a:ext cx="12191695" cy="6858000"/>
+          </a:xfrm>
+          <a:prstGeom prst="rect">
+            <a:avLst/>
+          </a:prstGeom>
+          <a:solidFill>
+            <a:srgbClr val="FFFFFF"/>
+          </a:solidFill>
+          <a:ln>
+            <a:noFill/>
+          </a:ln>
+        </p:spPr>
+        <p:style>
+          <a:lnRef idx="1">
+            <a:schemeClr val="accent1"/>
+          </a:lnRef>
+          <a:fillRef idx="3">
+            <a:schemeClr val="accent1"/>
+          </a:fillRef>
+          <a:effectRef idx="2">
+            <a:schemeClr val="accent1"/>
+          </a:effectRef>
+          <a:fontRef idx="minor">
+            <a:schemeClr val="lt1"/>
+          </a:fontRef>
+        </p:style>
+        <p:txBody>
+          <a:bodyPr rtlCol="0" anchor="ctr"/>
+          <a:lstStyle/>
+          <a:p>
+            <a:pPr algn="ctr"/>
+          </a:p>
+        </p:txBody>
+      </p:sp>
+      <p:sp>
+        <p:nvSpPr>
+          <p:cNvPr id="3" name="Rectangle 2"/>
+          <p:cNvSpPr/>
+          <p:nvPr/>
+        </p:nvSpPr>
+        <p:spPr>
+          <a:xfrm>
             <a:off x="548640" y="502920"/>
             <a:ext cx="109728" cy="822960"/>
           </a:xfrm>
@@ -5020,7 +5115,6 @@
           <a:ln>
             <a:noFill/>
           </a:ln>
-          <a:effectLst/>
         </p:spPr>
         <p:style>
           <a:lnRef idx="1">
@@ -5046,7 +5140,7 @@
       </p:sp>
       <p:sp>
         <p:nvSpPr>
-          <p:cNvPr id="3" name="TextBox 2"/>
+          <p:cNvPr id="4" name="TextBox 3"/>
           <p:cNvSpPr txBox="1"/>
           <p:nvPr/>
         </p:nvSpPr>
@@ -5081,7 +5175,7 @@
       </p:sp>
       <p:sp>
         <p:nvSpPr>
-          <p:cNvPr id="4" name="TextBox 3"/>
+          <p:cNvPr id="5" name="TextBox 4"/>
           <p:cNvSpPr txBox="1"/>
           <p:nvPr/>
         </p:nvSpPr>
@@ -5116,7 +5210,7 @@
       </p:sp>
       <p:sp>
         <p:nvSpPr>
-          <p:cNvPr id="5" name="TextBox 4"/>
+          <p:cNvPr id="6" name="TextBox 5"/>
           <p:cNvSpPr txBox="1"/>
           <p:nvPr/>
         </p:nvSpPr>
@@ -5276,14 +5370,6 @@
 <file path=ppt/slides/slide3.xml><?xml version="1.0" encoding="utf-8"?>
 <p:sld xmlns:a="http://schemas.openxmlformats.org/drawingml/2006/main" xmlns:p="http://schemas.openxmlformats.org/presentationml/2006/main" xmlns:r="http://schemas.openxmlformats.org/officeDocument/2006/relationships">
   <p:cSld>
-    <p:bg>
-      <p:bgPr>
-        <a:solidFill>
-          <a:srgbClr val="FFFFFF"/>
-        </a:solidFill>
-        <a:effectLst/>
-      </p:bgPr>
-    </p:bg>
     <p:spTree>
       <p:nvGrpSpPr>
         <p:cNvPr id="1" name=""/>
@@ -5299,6 +5385,49 @@
         </p:nvSpPr>
         <p:spPr>
           <a:xfrm>
+            <a:off x="0" y="0"/>
+            <a:ext cx="12191695" cy="6858000"/>
+          </a:xfrm>
+          <a:prstGeom prst="rect">
+            <a:avLst/>
+          </a:prstGeom>
+          <a:solidFill>
+            <a:srgbClr val="FFFFFF"/>
+          </a:solidFill>
+          <a:ln>
+            <a:noFill/>
+          </a:ln>
+        </p:spPr>
+        <p:style>
+          <a:lnRef idx="1">
+            <a:schemeClr val="accent1"/>
+          </a:lnRef>
+          <a:fillRef idx="3">
+            <a:schemeClr val="accent1"/>
+          </a:fillRef>
+          <a:effectRef idx="2">
+            <a:schemeClr val="accent1"/>
+          </a:effectRef>
+          <a:fontRef idx="minor">
+            <a:schemeClr val="lt1"/>
+          </a:fontRef>
+        </p:style>
+        <p:txBody>
+          <a:bodyPr rtlCol="0" anchor="ctr"/>
+          <a:lstStyle/>
+          <a:p>
+            <a:pPr algn="ctr"/>
+          </a:p>
+        </p:txBody>
+      </p:sp>
+      <p:sp>
+        <p:nvSpPr>
+          <p:cNvPr id="3" name="Rectangle 2"/>
+          <p:cNvSpPr/>
+          <p:nvPr/>
+        </p:nvSpPr>
+        <p:spPr>
+          <a:xfrm>
             <a:off x="548640" y="502920"/>
             <a:ext cx="109728" cy="822960"/>
           </a:xfrm>
@@ -5311,7 +5440,6 @@
           <a:ln>
             <a:noFill/>
           </a:ln>
-          <a:effectLst/>
         </p:spPr>
         <p:style>
           <a:lnRef idx="1">
@@ -5337,7 +5465,7 @@
       </p:sp>
       <p:sp>
         <p:nvSpPr>
-          <p:cNvPr id="3" name="TextBox 2"/>
+          <p:cNvPr id="4" name="TextBox 3"/>
           <p:cNvSpPr txBox="1"/>
           <p:nvPr/>
         </p:nvSpPr>
@@ -5372,7 +5500,7 @@
       </p:sp>
       <p:sp>
         <p:nvSpPr>
-          <p:cNvPr id="4" name="TextBox 3"/>
+          <p:cNvPr id="5" name="TextBox 4"/>
           <p:cNvSpPr txBox="1"/>
           <p:nvPr/>
         </p:nvSpPr>
@@ -5407,7 +5535,7 @@
       </p:sp>
       <p:sp>
         <p:nvSpPr>
-          <p:cNvPr id="5" name="TextBox 4"/>
+          <p:cNvPr id="6" name="TextBox 5"/>
           <p:cNvSpPr txBox="1"/>
           <p:nvPr/>
         </p:nvSpPr>
@@ -5478,7 +5606,7 @@
       </p:sp>
       <p:sp>
         <p:nvSpPr>
-          <p:cNvPr id="6" name="TextBox 5"/>
+          <p:cNvPr id="7" name="TextBox 6"/>
           <p:cNvSpPr txBox="1"/>
           <p:nvPr/>
         </p:nvSpPr>
@@ -5522,14 +5650,6 @@
 <file path=ppt/slides/slide4.xml><?xml version="1.0" encoding="utf-8"?>
 <p:sld xmlns:a="http://schemas.openxmlformats.org/drawingml/2006/main" xmlns:p="http://schemas.openxmlformats.org/presentationml/2006/main" xmlns:r="http://schemas.openxmlformats.org/officeDocument/2006/relationships">
   <p:cSld>
-    <p:bg>
-      <p:bgPr>
-        <a:solidFill>
-          <a:srgbClr val="FFFFFF"/>
-        </a:solidFill>
-        <a:effectLst/>
-      </p:bgPr>
-    </p:bg>
     <p:spTree>
       <p:nvGrpSpPr>
         <p:cNvPr id="1" name=""/>
@@ -5545,6 +5665,49 @@
         </p:nvSpPr>
         <p:spPr>
           <a:xfrm>
+            <a:off x="0" y="0"/>
+            <a:ext cx="12191695" cy="6858000"/>
+          </a:xfrm>
+          <a:prstGeom prst="rect">
+            <a:avLst/>
+          </a:prstGeom>
+          <a:solidFill>
+            <a:srgbClr val="FFFFFF"/>
+          </a:solidFill>
+          <a:ln>
+            <a:noFill/>
+          </a:ln>
+        </p:spPr>
+        <p:style>
+          <a:lnRef idx="1">
+            <a:schemeClr val="accent1"/>
+          </a:lnRef>
+          <a:fillRef idx="3">
+            <a:schemeClr val="accent1"/>
+          </a:fillRef>
+          <a:effectRef idx="2">
+            <a:schemeClr val="accent1"/>
+          </a:effectRef>
+          <a:fontRef idx="minor">
+            <a:schemeClr val="lt1"/>
+          </a:fontRef>
+        </p:style>
+        <p:txBody>
+          <a:bodyPr rtlCol="0" anchor="ctr"/>
+          <a:lstStyle/>
+          <a:p>
+            <a:pPr algn="ctr"/>
+          </a:p>
+        </p:txBody>
+      </p:sp>
+      <p:sp>
+        <p:nvSpPr>
+          <p:cNvPr id="3" name="Rectangle 2"/>
+          <p:cNvSpPr/>
+          <p:nvPr/>
+        </p:nvSpPr>
+        <p:spPr>
+          <a:xfrm>
             <a:off x="548640" y="502920"/>
             <a:ext cx="109728" cy="822960"/>
           </a:xfrm>
@@ -5557,7 +5720,6 @@
           <a:ln>
             <a:noFill/>
           </a:ln>
-          <a:effectLst/>
         </p:spPr>
         <p:style>
           <a:lnRef idx="1">
@@ -5583,7 +5745,7 @@
       </p:sp>
       <p:sp>
         <p:nvSpPr>
-          <p:cNvPr id="3" name="TextBox 2"/>
+          <p:cNvPr id="4" name="TextBox 3"/>
           <p:cNvSpPr txBox="1"/>
           <p:nvPr/>
         </p:nvSpPr>
@@ -5618,7 +5780,7 @@
       </p:sp>
       <p:sp>
         <p:nvSpPr>
-          <p:cNvPr id="4" name="TextBox 3"/>
+          <p:cNvPr id="5" name="TextBox 4"/>
           <p:cNvSpPr txBox="1"/>
           <p:nvPr/>
         </p:nvSpPr>
@@ -5653,7 +5815,7 @@
       </p:sp>
       <p:sp>
         <p:nvSpPr>
-          <p:cNvPr id="5" name="TextBox 4"/>
+          <p:cNvPr id="6" name="TextBox 5"/>
           <p:cNvSpPr txBox="1"/>
           <p:nvPr/>
         </p:nvSpPr>
@@ -5804,7 +5966,7 @@
       </p:sp>
       <p:sp>
         <p:nvSpPr>
-          <p:cNvPr id="6" name="Rectangle 5"/>
+          <p:cNvPr id="7" name="Rectangle 6"/>
           <p:cNvSpPr/>
           <p:nvPr/>
         </p:nvSpPr>
@@ -5822,7 +5984,6 @@
           <a:ln>
             <a:noFill/>
           </a:ln>
-          <a:effectLst/>
         </p:spPr>
         <p:style>
           <a:lnRef idx="1">
@@ -5848,7 +6009,7 @@
       </p:sp>
       <p:sp>
         <p:nvSpPr>
-          <p:cNvPr id="7" name="TextBox 6"/>
+          <p:cNvPr id="8" name="TextBox 7"/>
           <p:cNvSpPr txBox="1"/>
           <p:nvPr/>
         </p:nvSpPr>
@@ -5892,14 +6053,6 @@
 <file path=ppt/slides/slide5.xml><?xml version="1.0" encoding="utf-8"?>
 <p:sld xmlns:a="http://schemas.openxmlformats.org/drawingml/2006/main" xmlns:p="http://schemas.openxmlformats.org/presentationml/2006/main" xmlns:r="http://schemas.openxmlformats.org/officeDocument/2006/relationships">
   <p:cSld>
-    <p:bg>
-      <p:bgPr>
-        <a:solidFill>
-          <a:srgbClr val="FFFFFF"/>
-        </a:solidFill>
-        <a:effectLst/>
-      </p:bgPr>
-    </p:bg>
     <p:spTree>
       <p:nvGrpSpPr>
         <p:cNvPr id="1" name=""/>
@@ -5915,6 +6068,49 @@
         </p:nvSpPr>
         <p:spPr>
           <a:xfrm>
+            <a:off x="0" y="0"/>
+            <a:ext cx="12191695" cy="6858000"/>
+          </a:xfrm>
+          <a:prstGeom prst="rect">
+            <a:avLst/>
+          </a:prstGeom>
+          <a:solidFill>
+            <a:srgbClr val="FFFFFF"/>
+          </a:solidFill>
+          <a:ln>
+            <a:noFill/>
+          </a:ln>
+        </p:spPr>
+        <p:style>
+          <a:lnRef idx="1">
+            <a:schemeClr val="accent1"/>
+          </a:lnRef>
+          <a:fillRef idx="3">
+            <a:schemeClr val="accent1"/>
+          </a:fillRef>
+          <a:effectRef idx="2">
+            <a:schemeClr val="accent1"/>
+          </a:effectRef>
+          <a:fontRef idx="minor">
+            <a:schemeClr val="lt1"/>
+          </a:fontRef>
+        </p:style>
+        <p:txBody>
+          <a:bodyPr rtlCol="0" anchor="ctr"/>
+          <a:lstStyle/>
+          <a:p>
+            <a:pPr algn="ctr"/>
+          </a:p>
+        </p:txBody>
+      </p:sp>
+      <p:sp>
+        <p:nvSpPr>
+          <p:cNvPr id="3" name="Rectangle 2"/>
+          <p:cNvSpPr/>
+          <p:nvPr/>
+        </p:nvSpPr>
+        <p:spPr>
+          <a:xfrm>
             <a:off x="548640" y="502920"/>
             <a:ext cx="109728" cy="822960"/>
           </a:xfrm>
@@ -5927,7 +6123,6 @@
           <a:ln>
             <a:noFill/>
           </a:ln>
-          <a:effectLst/>
         </p:spPr>
         <p:style>
           <a:lnRef idx="1">
@@ -5953,7 +6148,7 @@
       </p:sp>
       <p:sp>
         <p:nvSpPr>
-          <p:cNvPr id="3" name="TextBox 2"/>
+          <p:cNvPr id="4" name="TextBox 3"/>
           <p:cNvSpPr txBox="1"/>
           <p:nvPr/>
         </p:nvSpPr>
@@ -5988,7 +6183,7 @@
       </p:sp>
       <p:sp>
         <p:nvSpPr>
-          <p:cNvPr id="4" name="TextBox 3"/>
+          <p:cNvPr id="5" name="TextBox 4"/>
           <p:cNvSpPr txBox="1"/>
           <p:nvPr/>
         </p:nvSpPr>
@@ -6023,7 +6218,7 @@
       </p:sp>
       <p:sp>
         <p:nvSpPr>
-          <p:cNvPr id="5" name="Rectangle 4"/>
+          <p:cNvPr id="6" name="Rectangle 5"/>
           <p:cNvSpPr/>
           <p:nvPr/>
         </p:nvSpPr>
@@ -6041,7 +6236,6 @@
           <a:ln>
             <a:noFill/>
           </a:ln>
-          <a:effectLst/>
         </p:spPr>
         <p:style>
           <a:lnRef idx="1">
@@ -6067,7 +6261,7 @@
       </p:sp>
       <p:sp>
         <p:nvSpPr>
-          <p:cNvPr id="6" name="TextBox 5"/>
+          <p:cNvPr id="7" name="TextBox 6"/>
           <p:cNvSpPr txBox="1"/>
           <p:nvPr/>
         </p:nvSpPr>
@@ -6103,7 +6297,7 @@
       </p:sp>
       <p:sp>
         <p:nvSpPr>
-          <p:cNvPr id="7" name="TextBox 6"/>
+          <p:cNvPr id="8" name="TextBox 7"/>
           <p:cNvSpPr txBox="1"/>
           <p:nvPr/>
         </p:nvSpPr>
@@ -6138,7 +6332,7 @@
       </p:sp>
       <p:sp>
         <p:nvSpPr>
-          <p:cNvPr id="8" name="TextBox 7"/>
+          <p:cNvPr id="9" name="TextBox 8"/>
           <p:cNvSpPr txBox="1"/>
           <p:nvPr/>
         </p:nvSpPr>
@@ -6173,7 +6367,7 @@
       </p:sp>
       <p:sp>
         <p:nvSpPr>
-          <p:cNvPr id="9" name="Rectangle 8"/>
+          <p:cNvPr id="10" name="Rectangle 9"/>
           <p:cNvSpPr/>
           <p:nvPr/>
         </p:nvSpPr>
@@ -6191,7 +6385,6 @@
           <a:ln>
             <a:noFill/>
           </a:ln>
-          <a:effectLst/>
         </p:spPr>
         <p:style>
           <a:lnRef idx="1">
@@ -6217,7 +6410,7 @@
       </p:sp>
       <p:sp>
         <p:nvSpPr>
-          <p:cNvPr id="10" name="TextBox 9"/>
+          <p:cNvPr id="11" name="TextBox 10"/>
           <p:cNvSpPr txBox="1"/>
           <p:nvPr/>
         </p:nvSpPr>
@@ -6253,7 +6446,7 @@
       </p:sp>
       <p:sp>
         <p:nvSpPr>
-          <p:cNvPr id="11" name="TextBox 10"/>
+          <p:cNvPr id="12" name="TextBox 11"/>
           <p:cNvSpPr txBox="1"/>
           <p:nvPr/>
         </p:nvSpPr>
@@ -6288,7 +6481,7 @@
       </p:sp>
       <p:sp>
         <p:nvSpPr>
-          <p:cNvPr id="12" name="TextBox 11"/>
+          <p:cNvPr id="13" name="TextBox 12"/>
           <p:cNvSpPr txBox="1"/>
           <p:nvPr/>
         </p:nvSpPr>
@@ -6323,7 +6516,7 @@
       </p:sp>
       <p:sp>
         <p:nvSpPr>
-          <p:cNvPr id="13" name="Rectangle 12"/>
+          <p:cNvPr id="14" name="Rectangle 13"/>
           <p:cNvSpPr/>
           <p:nvPr/>
         </p:nvSpPr>
@@ -6341,7 +6534,6 @@
           <a:ln>
             <a:noFill/>
           </a:ln>
-          <a:effectLst/>
         </p:spPr>
         <p:style>
           <a:lnRef idx="1">
@@ -6367,7 +6559,7 @@
       </p:sp>
       <p:sp>
         <p:nvSpPr>
-          <p:cNvPr id="14" name="TextBox 13"/>
+          <p:cNvPr id="15" name="TextBox 14"/>
           <p:cNvSpPr txBox="1"/>
           <p:nvPr/>
         </p:nvSpPr>
@@ -6403,7 +6595,7 @@
       </p:sp>
       <p:sp>
         <p:nvSpPr>
-          <p:cNvPr id="15" name="TextBox 14"/>
+          <p:cNvPr id="16" name="TextBox 15"/>
           <p:cNvSpPr txBox="1"/>
           <p:nvPr/>
         </p:nvSpPr>
@@ -6438,7 +6630,7 @@
       </p:sp>
       <p:sp>
         <p:nvSpPr>
-          <p:cNvPr id="16" name="TextBox 15"/>
+          <p:cNvPr id="17" name="TextBox 16"/>
           <p:cNvSpPr txBox="1"/>
           <p:nvPr/>
         </p:nvSpPr>
@@ -6473,7 +6665,7 @@
       </p:sp>
       <p:sp>
         <p:nvSpPr>
-          <p:cNvPr id="17" name="Rectangle 16"/>
+          <p:cNvPr id="18" name="Rectangle 17"/>
           <p:cNvSpPr/>
           <p:nvPr/>
         </p:nvSpPr>
@@ -6491,7 +6683,6 @@
           <a:ln>
             <a:noFill/>
           </a:ln>
-          <a:effectLst/>
         </p:spPr>
         <p:style>
           <a:lnRef idx="1">
@@ -6517,7 +6708,7 @@
       </p:sp>
       <p:sp>
         <p:nvSpPr>
-          <p:cNvPr id="18" name="TextBox 17"/>
+          <p:cNvPr id="19" name="TextBox 18"/>
           <p:cNvSpPr txBox="1"/>
           <p:nvPr/>
         </p:nvSpPr>
@@ -6553,7 +6744,7 @@
       </p:sp>
       <p:sp>
         <p:nvSpPr>
-          <p:cNvPr id="19" name="TextBox 18"/>
+          <p:cNvPr id="20" name="TextBox 19"/>
           <p:cNvSpPr txBox="1"/>
           <p:nvPr/>
         </p:nvSpPr>
@@ -6588,7 +6779,7 @@
       </p:sp>
       <p:sp>
         <p:nvSpPr>
-          <p:cNvPr id="20" name="TextBox 19"/>
+          <p:cNvPr id="21" name="TextBox 20"/>
           <p:cNvSpPr txBox="1"/>
           <p:nvPr/>
         </p:nvSpPr>
@@ -6632,14 +6823,6 @@
 <file path=ppt/slides/slide6.xml><?xml version="1.0" encoding="utf-8"?>
 <p:sld xmlns:a="http://schemas.openxmlformats.org/drawingml/2006/main" xmlns:p="http://schemas.openxmlformats.org/presentationml/2006/main" xmlns:r="http://schemas.openxmlformats.org/officeDocument/2006/relationships">
   <p:cSld>
-    <p:bg>
-      <p:bgPr>
-        <a:solidFill>
-          <a:srgbClr val="FFFFFF"/>
-        </a:solidFill>
-        <a:effectLst/>
-      </p:bgPr>
-    </p:bg>
     <p:spTree>
       <p:nvGrpSpPr>
         <p:cNvPr id="1" name=""/>
@@ -6655,6 +6838,49 @@
         </p:nvSpPr>
         <p:spPr>
           <a:xfrm>
+            <a:off x="0" y="0"/>
+            <a:ext cx="12191695" cy="6858000"/>
+          </a:xfrm>
+          <a:prstGeom prst="rect">
+            <a:avLst/>
+          </a:prstGeom>
+          <a:solidFill>
+            <a:srgbClr val="FFFFFF"/>
+          </a:solidFill>
+          <a:ln>
+            <a:noFill/>
+          </a:ln>
+        </p:spPr>
+        <p:style>
+          <a:lnRef idx="1">
+            <a:schemeClr val="accent1"/>
+          </a:lnRef>
+          <a:fillRef idx="3">
+            <a:schemeClr val="accent1"/>
+          </a:fillRef>
+          <a:effectRef idx="2">
+            <a:schemeClr val="accent1"/>
+          </a:effectRef>
+          <a:fontRef idx="minor">
+            <a:schemeClr val="lt1"/>
+          </a:fontRef>
+        </p:style>
+        <p:txBody>
+          <a:bodyPr rtlCol="0" anchor="ctr"/>
+          <a:lstStyle/>
+          <a:p>
+            <a:pPr algn="ctr"/>
+          </a:p>
+        </p:txBody>
+      </p:sp>
+      <p:sp>
+        <p:nvSpPr>
+          <p:cNvPr id="3" name="Rectangle 2"/>
+          <p:cNvSpPr/>
+          <p:nvPr/>
+        </p:nvSpPr>
+        <p:spPr>
+          <a:xfrm>
             <a:off x="548640" y="502920"/>
             <a:ext cx="109728" cy="822960"/>
           </a:xfrm>
@@ -6667,7 +6893,6 @@
           <a:ln>
             <a:noFill/>
           </a:ln>
-          <a:effectLst/>
         </p:spPr>
         <p:style>
           <a:lnRef idx="1">
@@ -6693,7 +6918,7 @@
       </p:sp>
       <p:sp>
         <p:nvSpPr>
-          <p:cNvPr id="3" name="TextBox 2"/>
+          <p:cNvPr id="4" name="TextBox 3"/>
           <p:cNvSpPr txBox="1"/>
           <p:nvPr/>
         </p:nvSpPr>
@@ -6728,7 +6953,7 @@
       </p:sp>
       <p:sp>
         <p:nvSpPr>
-          <p:cNvPr id="4" name="TextBox 3"/>
+          <p:cNvPr id="5" name="TextBox 4"/>
           <p:cNvSpPr txBox="1"/>
           <p:nvPr/>
         </p:nvSpPr>
@@ -6763,7 +6988,7 @@
       </p:sp>
       <p:sp>
         <p:nvSpPr>
-          <p:cNvPr id="5" name="Rectangle 4"/>
+          <p:cNvPr id="6" name="Rectangle 5"/>
           <p:cNvSpPr/>
           <p:nvPr/>
         </p:nvSpPr>
@@ -6781,7 +7006,6 @@
           <a:ln>
             <a:noFill/>
           </a:ln>
-          <a:effectLst/>
         </p:spPr>
         <p:style>
           <a:lnRef idx="1">
@@ -6807,7 +7031,7 @@
       </p:sp>
       <p:sp>
         <p:nvSpPr>
-          <p:cNvPr id="6" name="TextBox 5"/>
+          <p:cNvPr id="7" name="TextBox 6"/>
           <p:cNvSpPr txBox="1"/>
           <p:nvPr/>
         </p:nvSpPr>
@@ -6842,7 +7066,7 @@
       </p:sp>
       <p:sp>
         <p:nvSpPr>
-          <p:cNvPr id="7" name="TextBox 6"/>
+          <p:cNvPr id="8" name="TextBox 7"/>
           <p:cNvSpPr txBox="1"/>
           <p:nvPr/>
         </p:nvSpPr>
@@ -6877,7 +7101,7 @@
       </p:sp>
       <p:sp>
         <p:nvSpPr>
-          <p:cNvPr id="8" name="Rectangle 7"/>
+          <p:cNvPr id="9" name="Rectangle 8"/>
           <p:cNvSpPr/>
           <p:nvPr/>
         </p:nvSpPr>
@@ -6895,7 +7119,6 @@
           <a:ln>
             <a:noFill/>
           </a:ln>
-          <a:effectLst/>
         </p:spPr>
         <p:style>
           <a:lnRef idx="1">
@@ -6921,7 +7144,7 @@
       </p:sp>
       <p:sp>
         <p:nvSpPr>
-          <p:cNvPr id="9" name="TextBox 8"/>
+          <p:cNvPr id="10" name="TextBox 9"/>
           <p:cNvSpPr txBox="1"/>
           <p:nvPr/>
         </p:nvSpPr>
@@ -6956,7 +7179,7 @@
       </p:sp>
       <p:sp>
         <p:nvSpPr>
-          <p:cNvPr id="10" name="TextBox 9"/>
+          <p:cNvPr id="11" name="TextBox 10"/>
           <p:cNvSpPr txBox="1"/>
           <p:nvPr/>
         </p:nvSpPr>
@@ -6991,7 +7214,7 @@
       </p:sp>
       <p:sp>
         <p:nvSpPr>
-          <p:cNvPr id="11" name="Rectangle 10"/>
+          <p:cNvPr id="12" name="Rectangle 11"/>
           <p:cNvSpPr/>
           <p:nvPr/>
         </p:nvSpPr>
@@ -7009,7 +7232,6 @@
           <a:ln>
             <a:noFill/>
           </a:ln>
-          <a:effectLst/>
         </p:spPr>
         <p:style>
           <a:lnRef idx="1">
@@ -7035,7 +7257,7 @@
       </p:sp>
       <p:sp>
         <p:nvSpPr>
-          <p:cNvPr id="12" name="TextBox 11"/>
+          <p:cNvPr id="13" name="TextBox 12"/>
           <p:cNvSpPr txBox="1"/>
           <p:nvPr/>
         </p:nvSpPr>
@@ -7070,7 +7292,7 @@
       </p:sp>
       <p:sp>
         <p:nvSpPr>
-          <p:cNvPr id="13" name="TextBox 12"/>
+          <p:cNvPr id="14" name="TextBox 13"/>
           <p:cNvSpPr txBox="1"/>
           <p:nvPr/>
         </p:nvSpPr>
@@ -7105,7 +7327,7 @@
       </p:sp>
       <p:sp>
         <p:nvSpPr>
-          <p:cNvPr id="14" name="Rectangle 13"/>
+          <p:cNvPr id="15" name="Rectangle 14"/>
           <p:cNvSpPr/>
           <p:nvPr/>
         </p:nvSpPr>
@@ -7123,7 +7345,6 @@
           <a:ln>
             <a:noFill/>
           </a:ln>
-          <a:effectLst/>
         </p:spPr>
         <p:style>
           <a:lnRef idx="1">
@@ -7149,7 +7370,7 @@
       </p:sp>
       <p:sp>
         <p:nvSpPr>
-          <p:cNvPr id="15" name="TextBox 14"/>
+          <p:cNvPr id="16" name="TextBox 15"/>
           <p:cNvSpPr txBox="1"/>
           <p:nvPr/>
         </p:nvSpPr>
@@ -7184,7 +7405,7 @@
       </p:sp>
       <p:sp>
         <p:nvSpPr>
-          <p:cNvPr id="16" name="TextBox 15"/>
+          <p:cNvPr id="17" name="TextBox 16"/>
           <p:cNvSpPr txBox="1"/>
           <p:nvPr/>
         </p:nvSpPr>
@@ -7228,14 +7449,6 @@
 <file path=ppt/slides/slide7.xml><?xml version="1.0" encoding="utf-8"?>
 <p:sld xmlns:a="http://schemas.openxmlformats.org/drawingml/2006/main" xmlns:p="http://schemas.openxmlformats.org/presentationml/2006/main" xmlns:r="http://schemas.openxmlformats.org/officeDocument/2006/relationships">
   <p:cSld>
-    <p:bg>
-      <p:bgPr>
-        <a:solidFill>
-          <a:srgbClr val="11141A"/>
-        </a:solidFill>
-        <a:effectLst/>
-      </p:bgPr>
-    </p:bg>
     <p:spTree>
       <p:nvGrpSpPr>
         <p:cNvPr id="1" name=""/>
@@ -7251,6 +7464,49 @@
         </p:nvSpPr>
         <p:spPr>
           <a:xfrm>
+            <a:off x="0" y="0"/>
+            <a:ext cx="12191695" cy="6858000"/>
+          </a:xfrm>
+          <a:prstGeom prst="rect">
+            <a:avLst/>
+          </a:prstGeom>
+          <a:solidFill>
+            <a:srgbClr val="11141A"/>
+          </a:solidFill>
+          <a:ln>
+            <a:noFill/>
+          </a:ln>
+        </p:spPr>
+        <p:style>
+          <a:lnRef idx="1">
+            <a:schemeClr val="accent1"/>
+          </a:lnRef>
+          <a:fillRef idx="3">
+            <a:schemeClr val="accent1"/>
+          </a:fillRef>
+          <a:effectRef idx="2">
+            <a:schemeClr val="accent1"/>
+          </a:effectRef>
+          <a:fontRef idx="minor">
+            <a:schemeClr val="lt1"/>
+          </a:fontRef>
+        </p:style>
+        <p:txBody>
+          <a:bodyPr rtlCol="0" anchor="ctr"/>
+          <a:lstStyle/>
+          <a:p>
+            <a:pPr algn="ctr"/>
+          </a:p>
+        </p:txBody>
+      </p:sp>
+      <p:sp>
+        <p:nvSpPr>
+          <p:cNvPr id="3" name="Rectangle 2"/>
+          <p:cNvSpPr/>
+          <p:nvPr/>
+        </p:nvSpPr>
+        <p:spPr>
+          <a:xfrm>
             <a:off x="548640" y="502920"/>
             <a:ext cx="109728" cy="822960"/>
           </a:xfrm>
@@ -7263,7 +7519,6 @@
           <a:ln>
             <a:noFill/>
           </a:ln>
-          <a:effectLst/>
         </p:spPr>
         <p:style>
           <a:lnRef idx="1">
@@ -7289,7 +7544,7 @@
       </p:sp>
       <p:sp>
         <p:nvSpPr>
-          <p:cNvPr id="3" name="TextBox 2"/>
+          <p:cNvPr id="4" name="TextBox 3"/>
           <p:cNvSpPr txBox="1"/>
           <p:nvPr/>
         </p:nvSpPr>
@@ -7324,7 +7579,7 @@
       </p:sp>
       <p:sp>
         <p:nvSpPr>
-          <p:cNvPr id="4" name="TextBox 3"/>
+          <p:cNvPr id="5" name="TextBox 4"/>
           <p:cNvSpPr txBox="1"/>
           <p:nvPr/>
         </p:nvSpPr>
@@ -7359,7 +7614,7 @@
       </p:sp>
       <p:sp>
         <p:nvSpPr>
-          <p:cNvPr id="5" name="TextBox 4"/>
+          <p:cNvPr id="6" name="TextBox 5"/>
           <p:cNvSpPr txBox="1"/>
           <p:nvPr/>
         </p:nvSpPr>
@@ -7394,7 +7649,7 @@
       </p:sp>
       <p:sp>
         <p:nvSpPr>
-          <p:cNvPr id="6" name="TextBox 5"/>
+          <p:cNvPr id="7" name="TextBox 6"/>
           <p:cNvSpPr txBox="1"/>
           <p:nvPr/>
         </p:nvSpPr>
@@ -7429,7 +7684,7 @@
       </p:sp>
       <p:sp>
         <p:nvSpPr>
-          <p:cNvPr id="7" name="TextBox 6"/>
+          <p:cNvPr id="8" name="TextBox 7"/>
           <p:cNvSpPr txBox="1"/>
           <p:nvPr/>
         </p:nvSpPr>
@@ -7464,7 +7719,7 @@
       </p:sp>
       <p:sp>
         <p:nvSpPr>
-          <p:cNvPr id="8" name="TextBox 7"/>
+          <p:cNvPr id="9" name="TextBox 8"/>
           <p:cNvSpPr txBox="1"/>
           <p:nvPr/>
         </p:nvSpPr>
@@ -7499,7 +7754,7 @@
       </p:sp>
       <p:sp>
         <p:nvSpPr>
-          <p:cNvPr id="9" name="Rectangle 8"/>
+          <p:cNvPr id="10" name="Rectangle 9"/>
           <p:cNvSpPr/>
           <p:nvPr/>
         </p:nvSpPr>
@@ -7517,7 +7772,6 @@
           <a:ln>
             <a:noFill/>
           </a:ln>
-          <a:effectLst/>
         </p:spPr>
         <p:style>
           <a:lnRef idx="1">
@@ -7543,7 +7797,7 @@
       </p:sp>
       <p:sp>
         <p:nvSpPr>
-          <p:cNvPr id="10" name="TextBox 9"/>
+          <p:cNvPr id="11" name="TextBox 10"/>
           <p:cNvSpPr txBox="1"/>
           <p:nvPr/>
         </p:nvSpPr>
@@ -7578,7 +7832,7 @@
       </p:sp>
       <p:sp>
         <p:nvSpPr>
-          <p:cNvPr id="11" name="TextBox 10"/>
+          <p:cNvPr id="12" name="TextBox 11"/>
           <p:cNvSpPr txBox="1"/>
           <p:nvPr/>
         </p:nvSpPr>
@@ -7613,7 +7867,7 @@
       </p:sp>
       <p:sp>
         <p:nvSpPr>
-          <p:cNvPr id="12" name="TextBox 11"/>
+          <p:cNvPr id="13" name="TextBox 12"/>
           <p:cNvSpPr txBox="1"/>
           <p:nvPr/>
         </p:nvSpPr>
@@ -7648,7 +7902,7 @@
       </p:sp>
       <p:sp>
         <p:nvSpPr>
-          <p:cNvPr id="13" name="TextBox 12"/>
+          <p:cNvPr id="14" name="TextBox 13"/>
           <p:cNvSpPr txBox="1"/>
           <p:nvPr/>
         </p:nvSpPr>
@@ -7692,14 +7946,6 @@
 <file path=ppt/slides/slide8.xml><?xml version="1.0" encoding="utf-8"?>
 <p:sld xmlns:a="http://schemas.openxmlformats.org/drawingml/2006/main" xmlns:p="http://schemas.openxmlformats.org/presentationml/2006/main" xmlns:r="http://schemas.openxmlformats.org/officeDocument/2006/relationships">
   <p:cSld>
-    <p:bg>
-      <p:bgPr>
-        <a:solidFill>
-          <a:srgbClr val="FFFFFF"/>
-        </a:solidFill>
-        <a:effectLst/>
-      </p:bgPr>
-    </p:bg>
     <p:spTree>
       <p:nvGrpSpPr>
         <p:cNvPr id="1" name=""/>
@@ -7715,6 +7961,49 @@
         </p:nvSpPr>
         <p:spPr>
           <a:xfrm>
+            <a:off x="0" y="0"/>
+            <a:ext cx="12191695" cy="6858000"/>
+          </a:xfrm>
+          <a:prstGeom prst="rect">
+            <a:avLst/>
+          </a:prstGeom>
+          <a:solidFill>
+            <a:srgbClr val="FFFFFF"/>
+          </a:solidFill>
+          <a:ln>
+            <a:noFill/>
+          </a:ln>
+        </p:spPr>
+        <p:style>
+          <a:lnRef idx="1">
+            <a:schemeClr val="accent1"/>
+          </a:lnRef>
+          <a:fillRef idx="3">
+            <a:schemeClr val="accent1"/>
+          </a:fillRef>
+          <a:effectRef idx="2">
+            <a:schemeClr val="accent1"/>
+          </a:effectRef>
+          <a:fontRef idx="minor">
+            <a:schemeClr val="lt1"/>
+          </a:fontRef>
+        </p:style>
+        <p:txBody>
+          <a:bodyPr rtlCol="0" anchor="ctr"/>
+          <a:lstStyle/>
+          <a:p>
+            <a:pPr algn="ctr"/>
+          </a:p>
+        </p:txBody>
+      </p:sp>
+      <p:sp>
+        <p:nvSpPr>
+          <p:cNvPr id="3" name="Rectangle 2"/>
+          <p:cNvSpPr/>
+          <p:nvPr/>
+        </p:nvSpPr>
+        <p:spPr>
+          <a:xfrm>
             <a:off x="548640" y="502920"/>
             <a:ext cx="109728" cy="822960"/>
           </a:xfrm>
@@ -7727,7 +8016,6 @@
           <a:ln>
             <a:noFill/>
           </a:ln>
-          <a:effectLst/>
         </p:spPr>
         <p:style>
           <a:lnRef idx="1">
@@ -7753,7 +8041,7 @@
       </p:sp>
       <p:sp>
         <p:nvSpPr>
-          <p:cNvPr id="3" name="TextBox 2"/>
+          <p:cNvPr id="4" name="TextBox 3"/>
           <p:cNvSpPr txBox="1"/>
           <p:nvPr/>
         </p:nvSpPr>
@@ -7788,7 +8076,7 @@
       </p:sp>
       <p:sp>
         <p:nvSpPr>
-          <p:cNvPr id="4" name="TextBox 3"/>
+          <p:cNvPr id="5" name="TextBox 4"/>
           <p:cNvSpPr txBox="1"/>
           <p:nvPr/>
         </p:nvSpPr>
@@ -7823,7 +8111,7 @@
       </p:sp>
       <p:sp>
         <p:nvSpPr>
-          <p:cNvPr id="5" name="TextBox 4"/>
+          <p:cNvPr id="6" name="TextBox 5"/>
           <p:cNvSpPr txBox="1"/>
           <p:nvPr/>
         </p:nvSpPr>
@@ -7958,7 +8246,7 @@
       </p:sp>
       <p:sp>
         <p:nvSpPr>
-          <p:cNvPr id="6" name="Rectangle 5"/>
+          <p:cNvPr id="7" name="Rectangle 6"/>
           <p:cNvSpPr/>
           <p:nvPr/>
         </p:nvSpPr>
@@ -7976,7 +8264,6 @@
           <a:ln>
             <a:noFill/>
           </a:ln>
-          <a:effectLst/>
         </p:spPr>
         <p:style>
           <a:lnRef idx="1">
@@ -8002,7 +8289,7 @@
       </p:sp>
       <p:sp>
         <p:nvSpPr>
-          <p:cNvPr id="7" name="TextBox 6"/>
+          <p:cNvPr id="8" name="TextBox 7"/>
           <p:cNvSpPr txBox="1"/>
           <p:nvPr/>
         </p:nvSpPr>
@@ -8046,14 +8333,6 @@
 <file path=ppt/slides/slide9.xml><?xml version="1.0" encoding="utf-8"?>
 <p:sld xmlns:a="http://schemas.openxmlformats.org/drawingml/2006/main" xmlns:p="http://schemas.openxmlformats.org/presentationml/2006/main" xmlns:r="http://schemas.openxmlformats.org/officeDocument/2006/relationships">
   <p:cSld>
-    <p:bg>
-      <p:bgPr>
-        <a:solidFill>
-          <a:srgbClr val="FFFFFF"/>
-        </a:solidFill>
-        <a:effectLst/>
-      </p:bgPr>
-    </p:bg>
     <p:spTree>
       <p:nvGrpSpPr>
         <p:cNvPr id="1" name=""/>
@@ -8069,6 +8348,49 @@
         </p:nvSpPr>
         <p:spPr>
           <a:xfrm>
+            <a:off x="0" y="0"/>
+            <a:ext cx="12191695" cy="6858000"/>
+          </a:xfrm>
+          <a:prstGeom prst="rect">
+            <a:avLst/>
+          </a:prstGeom>
+          <a:solidFill>
+            <a:srgbClr val="FFFFFF"/>
+          </a:solidFill>
+          <a:ln>
+            <a:noFill/>
+          </a:ln>
+        </p:spPr>
+        <p:style>
+          <a:lnRef idx="1">
+            <a:schemeClr val="accent1"/>
+          </a:lnRef>
+          <a:fillRef idx="3">
+            <a:schemeClr val="accent1"/>
+          </a:fillRef>
+          <a:effectRef idx="2">
+            <a:schemeClr val="accent1"/>
+          </a:effectRef>
+          <a:fontRef idx="minor">
+            <a:schemeClr val="lt1"/>
+          </a:fontRef>
+        </p:style>
+        <p:txBody>
+          <a:bodyPr rtlCol="0" anchor="ctr"/>
+          <a:lstStyle/>
+          <a:p>
+            <a:pPr algn="ctr"/>
+          </a:p>
+        </p:txBody>
+      </p:sp>
+      <p:sp>
+        <p:nvSpPr>
+          <p:cNvPr id="3" name="Rectangle 2"/>
+          <p:cNvSpPr/>
+          <p:nvPr/>
+        </p:nvSpPr>
+        <p:spPr>
+          <a:xfrm>
             <a:off x="548640" y="502920"/>
             <a:ext cx="109728" cy="822960"/>
           </a:xfrm>
@@ -8081,7 +8403,6 @@
           <a:ln>
             <a:noFill/>
           </a:ln>
-          <a:effectLst/>
         </p:spPr>
         <p:style>
           <a:lnRef idx="1">
@@ -8107,7 +8428,7 @@
       </p:sp>
       <p:sp>
         <p:nvSpPr>
-          <p:cNvPr id="3" name="TextBox 2"/>
+          <p:cNvPr id="4" name="TextBox 3"/>
           <p:cNvSpPr txBox="1"/>
           <p:nvPr/>
         </p:nvSpPr>
@@ -8142,7 +8463,7 @@
       </p:sp>
       <p:sp>
         <p:nvSpPr>
-          <p:cNvPr id="4" name="TextBox 3"/>
+          <p:cNvPr id="5" name="TextBox 4"/>
           <p:cNvSpPr txBox="1"/>
           <p:nvPr/>
         </p:nvSpPr>
@@ -8177,7 +8498,7 @@
       </p:sp>
       <p:sp>
         <p:nvSpPr>
-          <p:cNvPr id="5" name="TextBox 4"/>
+          <p:cNvPr id="6" name="TextBox 5"/>
           <p:cNvSpPr txBox="1"/>
           <p:nvPr/>
         </p:nvSpPr>

</xml_diff>